<commit_message>
feat: add ip file and some doc
</commit_message>
<xml_diff>
--- a/figure/trq_minisys_fig.pptx
+++ b/figure/trq_minisys_fig.pptx
@@ -5,13 +5,14 @@
     <p:sldMasterId id="2147483648" r:id="rId1"/>
   </p:sldMasterIdLst>
   <p:notesMasterIdLst>
-    <p:notesMasterId r:id="rId7"/>
+    <p:notesMasterId r:id="rId8"/>
   </p:notesMasterIdLst>
   <p:sldIdLst>
     <p:sldId id="315" r:id="rId3"/>
     <p:sldId id="325" r:id="rId4"/>
     <p:sldId id="327" r:id="rId5"/>
     <p:sldId id="328" r:id="rId6"/>
+    <p:sldId id="330" r:id="rId7"/>
   </p:sldIdLst>
   <p:sldSz cx="12192000" cy="6858000"/>
   <p:notesSz cx="6858000" cy="9144000"/>
@@ -6916,7 +6917,7 @@
                 <a:cs typeface="Courier New Regular" panose="02070409020205090404" charset="0"/>
                 <a:sym typeface="苹方-简" panose="020B0400000000000000" charset="-122"/>
               </a:rPr>
-              <a:t>[4:0]rs1_0, rs2_0, rd_o</a:t>
+              <a:t>[4:0]rs1_o, rs2_o, rd_o</a:t>
             </a:r>
             <a:endParaRPr kumimoji="0" lang="en-US" altLang="zh-CN" sz="1400" b="0" i="0" u="none" strike="noStrike" cap="none" spc="0" normalizeH="0" baseline="0">
               <a:ln>
@@ -13583,6 +13584,2261 @@
               <a:latin typeface="Courier New Regular" panose="02070409020205090404" charset="0"/>
               <a:ea typeface="+mj-ea"/>
               <a:cs typeface="Courier New Regular" panose="02070409020205090404" charset="0"/>
+              <a:sym typeface="苹方-简" panose="020B0400000000000000" charset="-122"/>
+            </a:endParaRPr>
+          </a:p>
+        </p:txBody>
+      </p:sp>
+    </p:spTree>
+  </p:cSld>
+  <p:clrMapOvr>
+    <a:masterClrMapping/>
+  </p:clrMapOvr>
+  <p:transition spd="med"/>
+  <p:timing>
+    <p:tnLst>
+      <p:par>
+        <p:cTn id="1" dur="indefinite" restart="never" fill="hold" nodeType="tmRoot"/>
+      </p:par>
+    </p:tnLst>
+  </p:timing>
+</p:sld>
+</file>
+
+<file path=ppt/slides/slide5.xml><?xml version="1.0" encoding="utf-8"?>
+<p:sld xmlns:a="http://schemas.openxmlformats.org/drawingml/2006/main" xmlns:r="http://schemas.openxmlformats.org/officeDocument/2006/relationships" xmlns:p="http://schemas.openxmlformats.org/presentationml/2006/main">
+  <p:cSld>
+    <p:spTree>
+      <p:nvGrpSpPr>
+        <p:cNvPr id="1" name=""/>
+        <p:cNvGrpSpPr/>
+        <p:nvPr/>
+      </p:nvGrpSpPr>
+      <p:grpSpPr>
+        <a:xfrm>
+          <a:off x="0" y="0"/>
+          <a:ext cx="0" cy="0"/>
+          <a:chOff x="0" y="0"/>
+          <a:chExt cx="0" cy="0"/>
+        </a:xfrm>
+      </p:grpSpPr>
+      <p:sp>
+        <p:nvSpPr>
+          <p:cNvPr id="193" name="文本框 3"/>
+          <p:cNvSpPr txBox="1"/>
+          <p:nvPr/>
+        </p:nvSpPr>
+        <p:spPr>
+          <a:xfrm>
+            <a:off x="621171" y="404918"/>
+            <a:ext cx="11449150" cy="614045"/>
+          </a:xfrm>
+          <a:prstGeom prst="rect">
+            <a:avLst/>
+          </a:prstGeom>
+          <a:ln w="12700">
+            <a:miter lim="400000"/>
+          </a:ln>
+        </p:spPr>
+        <p:txBody>
+          <a:bodyPr lIns="45719" rIns="45719">
+            <a:spAutoFit/>
+          </a:bodyPr>
+          <a:lstStyle>
+            <a:lvl1pPr>
+              <a:defRPr sz="3400" b="1">
+                <a:solidFill>
+                  <a:srgbClr val="011993"/>
+                </a:solidFill>
+                <a:latin typeface="Arial" panose="020B0604020202090204"/>
+                <a:ea typeface="Arial" panose="020B0604020202090204"/>
+                <a:cs typeface="Arial" panose="020B0604020202090204"/>
+                <a:sym typeface="Arial" panose="020B0604020202090204"/>
+              </a:defRPr>
+            </a:lvl1pPr>
+          </a:lstStyle>
+          <a:p>
+            <a:r>
+              <a:rPr lang="en-US"/>
+              <a:t>IF</a:t>
+            </a:r>
+            <a:endParaRPr lang="en-US"/>
+          </a:p>
+        </p:txBody>
+      </p:sp>
+      <p:sp>
+        <p:nvSpPr>
+          <p:cNvPr id="2" name="矩形 1"/>
+          <p:cNvSpPr/>
+          <p:nvPr/>
+        </p:nvSpPr>
+        <p:spPr>
+          <a:xfrm>
+            <a:off x="5481955" y="968375"/>
+            <a:ext cx="902335" cy="4891405"/>
+          </a:xfrm>
+          <a:prstGeom prst="rect">
+            <a:avLst/>
+          </a:prstGeom>
+          <a:solidFill>
+            <a:srgbClr val="FFFFFF"/>
+          </a:solidFill>
+          <a:ln w="12700" cap="flat">
+            <a:solidFill>
+              <a:schemeClr val="accent1"/>
+            </a:solidFill>
+            <a:prstDash val="solid"/>
+            <a:miter lim="800000"/>
+          </a:ln>
+        </p:spPr>
+        <p:style>
+          <a:lnRef idx="0">
+            <a:srgbClr val="FFFFFF"/>
+          </a:lnRef>
+          <a:fillRef idx="0">
+            <a:srgbClr val="FFFFFF"/>
+          </a:fillRef>
+          <a:effectRef idx="0">
+            <a:srgbClr val="FFFFFF"/>
+          </a:effectRef>
+          <a:fontRef idx="none"/>
+        </p:style>
+        <p:txBody>
+          <a:bodyPr rot="0" vertOverflow="overflow" horzOverflow="overflow" vert="horz" wrap="square" lIns="0" tIns="0" rIns="0" bIns="0" numCol="1" spcCol="38100" rtlCol="0" anchor="t" forceAA="0" upright="0">
+            <a:noAutofit/>
+          </a:bodyPr>
+          <a:p>
+            <a:pPr marL="0" marR="0" indent="0" algn="l" defTabSz="914400" rtl="0" fontAlgn="auto" latinLnBrk="0" hangingPunct="0">
+              <a:lnSpc>
+                <a:spcPct val="100000"/>
+              </a:lnSpc>
+              <a:spcBef>
+                <a:spcPts val="0"/>
+              </a:spcBef>
+              <a:spcAft>
+                <a:spcPts val="0"/>
+              </a:spcAft>
+              <a:buClrTx/>
+              <a:buSzTx/>
+              <a:buFontTx/>
+              <a:buNone/>
+            </a:pPr>
+            <a:endParaRPr kumimoji="0" lang="zh-CN" altLang="en-US" sz="1800" b="0" i="0" u="none" strike="noStrike" cap="none" spc="0" normalizeH="0" baseline="0">
+              <a:ln>
+                <a:noFill/>
+              </a:ln>
+              <a:solidFill>
+                <a:srgbClr val="000000"/>
+              </a:solidFill>
+              <a:effectLst/>
+              <a:uFillTx/>
+              <a:latin typeface="+mj-lt"/>
+              <a:ea typeface="+mj-ea"/>
+              <a:cs typeface="+mj-cs"/>
+              <a:sym typeface="苹方-简" panose="020B0400000000000000" charset="-122"/>
+            </a:endParaRPr>
+          </a:p>
+        </p:txBody>
+      </p:sp>
+      <p:cxnSp>
+        <p:nvCxnSpPr>
+          <p:cNvPr id="4" name="直接箭头连接符 3"/>
+          <p:cNvCxnSpPr/>
+          <p:nvPr/>
+        </p:nvCxnSpPr>
+        <p:spPr>
+          <a:xfrm>
+            <a:off x="4617085" y="1162050"/>
+            <a:ext cx="864870" cy="15875"/>
+          </a:xfrm>
+          <a:prstGeom prst="straightConnector1">
+            <a:avLst/>
+          </a:prstGeom>
+          <a:noFill/>
+          <a:ln w="12700" cap="flat">
+            <a:solidFill>
+              <a:schemeClr val="accent1"/>
+            </a:solidFill>
+            <a:prstDash val="solid"/>
+            <a:miter lim="800000"/>
+            <a:tailEnd type="arrow"/>
+          </a:ln>
+          <a:effectLst>
+            <a:outerShdw blurRad="101600" dist="50800" dir="5400000" rotWithShape="0">
+              <a:schemeClr val="accent1">
+                <a:alpha val="60000"/>
+              </a:schemeClr>
+            </a:outerShdw>
+          </a:effectLst>
+        </p:spPr>
+        <p:style>
+          <a:lnRef idx="0">
+            <a:srgbClr val="FFFFFF"/>
+          </a:lnRef>
+          <a:fillRef idx="0">
+            <a:srgbClr val="FFFFFF"/>
+          </a:fillRef>
+          <a:effectRef idx="0">
+            <a:srgbClr val="FFFFFF"/>
+          </a:effectRef>
+          <a:fontRef idx="none"/>
+        </p:style>
+      </p:cxnSp>
+      <p:sp>
+        <p:nvSpPr>
+          <p:cNvPr id="5" name="文本框 4"/>
+          <p:cNvSpPr txBox="1"/>
+          <p:nvPr/>
+        </p:nvSpPr>
+        <p:spPr>
+          <a:xfrm>
+            <a:off x="2520950" y="892810"/>
+            <a:ext cx="1652905" cy="553720"/>
+          </a:xfrm>
+          <a:prstGeom prst="rect">
+            <a:avLst/>
+          </a:prstGeom>
+          <a:noFill/>
+          <a:ln w="12700" cap="flat">
+            <a:noFill/>
+            <a:miter lim="400000"/>
+          </a:ln>
+        </p:spPr>
+        <p:style>
+          <a:lnRef idx="0">
+            <a:srgbClr val="FFFFFF"/>
+          </a:lnRef>
+          <a:fillRef idx="0">
+            <a:srgbClr val="FFFFFF"/>
+          </a:fillRef>
+          <a:effectRef idx="0">
+            <a:srgbClr val="FFFFFF"/>
+          </a:effectRef>
+          <a:fontRef idx="none"/>
+        </p:style>
+        <p:txBody>
+          <a:bodyPr rot="0" vertOverflow="overflow" horzOverflow="overflow" vert="horz" wrap="square" lIns="0" tIns="0" rIns="0" bIns="0" numCol="1" spcCol="38100" rtlCol="0" anchor="t" forceAA="0" upright="0">
+            <a:spAutoFit/>
+          </a:bodyPr>
+          <a:p>
+            <a:pPr marL="0" marR="0" indent="0" algn="ctr" defTabSz="914400" rtl="0" fontAlgn="auto" latinLnBrk="0" hangingPunct="0">
+              <a:lnSpc>
+                <a:spcPct val="100000"/>
+              </a:lnSpc>
+              <a:spcBef>
+                <a:spcPts val="0"/>
+              </a:spcBef>
+              <a:spcAft>
+                <a:spcPts val="0"/>
+              </a:spcAft>
+              <a:buClrTx/>
+              <a:buSzTx/>
+              <a:buFontTx/>
+              <a:buNone/>
+            </a:pPr>
+            <a:r>
+              <a:rPr kumimoji="0" lang="zh-CN" altLang="en-US" sz="1800" b="0" i="0" u="none" strike="noStrike" cap="none" spc="0" normalizeH="0" baseline="0">
+                <a:ln>
+                  <a:noFill/>
+                </a:ln>
+                <a:solidFill>
+                  <a:srgbClr val="000000"/>
+                </a:solidFill>
+                <a:effectLst/>
+                <a:uFillTx/>
+                <a:latin typeface="+mj-lt"/>
+                <a:ea typeface="+mj-ea"/>
+                <a:cs typeface="+mj-cs"/>
+                <a:sym typeface="苹方-简" panose="020B0400000000000000" charset="-122"/>
+              </a:rPr>
+              <a:t>分支目标地址</a:t>
+            </a:r>
+            <a:r>
+              <a:rPr kumimoji="0" lang="en-US" altLang="zh-CN" sz="1800" b="0" i="0" u="none" strike="noStrike" cap="none" spc="0" normalizeH="0" baseline="0">
+                <a:ln>
+                  <a:noFill/>
+                </a:ln>
+                <a:solidFill>
+                  <a:srgbClr val="000000"/>
+                </a:solidFill>
+                <a:effectLst/>
+                <a:uFillTx/>
+                <a:latin typeface="+mj-lt"/>
+                <a:ea typeface="+mj-ea"/>
+                <a:cs typeface="+mj-cs"/>
+                <a:sym typeface="苹方-简" panose="020B0400000000000000" charset="-122"/>
+              </a:rPr>
+              <a:t> </a:t>
+            </a:r>
+            <a:r>
+              <a:rPr kumimoji="0" lang="en-US" altLang="zh-CN" sz="1800" i="0" u="none" strike="noStrike" cap="none" spc="0" normalizeH="0" baseline="0">
+                <a:ln>
+                  <a:noFill/>
+                </a:ln>
+                <a:solidFill>
+                  <a:srgbClr val="000000"/>
+                </a:solidFill>
+                <a:effectLst/>
+                <a:uFillTx/>
+                <a:latin typeface="Courier New Regular" panose="02070409020205090404" charset="0"/>
+                <a:ea typeface="PingFang SC Semibold" panose="020B0400000000000000" charset="-122"/>
+                <a:cs typeface="Courier New Regular" panose="02070409020205090404" charset="0"/>
+                <a:sym typeface="苹方-简" panose="020B0400000000000000" charset="-122"/>
+              </a:rPr>
+              <a:t>pc_branch_i</a:t>
+            </a:r>
+            <a:endParaRPr kumimoji="0" lang="en-US" altLang="zh-CN" sz="1800" i="0" u="none" strike="noStrike" cap="none" spc="0" normalizeH="0" baseline="0">
+              <a:ln>
+                <a:noFill/>
+              </a:ln>
+              <a:solidFill>
+                <a:srgbClr val="000000"/>
+              </a:solidFill>
+              <a:effectLst/>
+              <a:uFillTx/>
+              <a:latin typeface="Courier New Regular" panose="02070409020205090404" charset="0"/>
+              <a:ea typeface="PingFang SC Semibold" panose="020B0400000000000000" charset="-122"/>
+              <a:cs typeface="Courier New Regular" panose="02070409020205090404" charset="0"/>
+              <a:sym typeface="苹方-简" panose="020B0400000000000000" charset="-122"/>
+            </a:endParaRPr>
+          </a:p>
+        </p:txBody>
+      </p:sp>
+      <p:cxnSp>
+        <p:nvCxnSpPr>
+          <p:cNvPr id="6" name="直接箭头连接符 5"/>
+          <p:cNvCxnSpPr/>
+          <p:nvPr/>
+        </p:nvCxnSpPr>
+        <p:spPr>
+          <a:xfrm>
+            <a:off x="4617085" y="2223770"/>
+            <a:ext cx="864870" cy="15875"/>
+          </a:xfrm>
+          <a:prstGeom prst="straightConnector1">
+            <a:avLst/>
+          </a:prstGeom>
+          <a:noFill/>
+          <a:ln w="12700" cap="flat">
+            <a:solidFill>
+              <a:schemeClr val="accent1"/>
+            </a:solidFill>
+            <a:prstDash val="solid"/>
+            <a:miter lim="800000"/>
+            <a:tailEnd type="arrow"/>
+          </a:ln>
+          <a:effectLst>
+            <a:outerShdw blurRad="101600" dist="50800" dir="5400000" rotWithShape="0">
+              <a:schemeClr val="accent1">
+                <a:alpha val="60000"/>
+              </a:schemeClr>
+            </a:outerShdw>
+          </a:effectLst>
+        </p:spPr>
+        <p:style>
+          <a:lnRef idx="0">
+            <a:srgbClr val="FFFFFF"/>
+          </a:lnRef>
+          <a:fillRef idx="0">
+            <a:srgbClr val="FFFFFF"/>
+          </a:fillRef>
+          <a:effectRef idx="0">
+            <a:srgbClr val="FFFFFF"/>
+          </a:effectRef>
+          <a:fontRef idx="none"/>
+        </p:style>
+      </p:cxnSp>
+      <p:sp>
+        <p:nvSpPr>
+          <p:cNvPr id="7" name="文本框 6"/>
+          <p:cNvSpPr txBox="1"/>
+          <p:nvPr/>
+        </p:nvSpPr>
+        <p:spPr>
+          <a:xfrm>
+            <a:off x="1991360" y="1863090"/>
+            <a:ext cx="2470150" cy="553720"/>
+          </a:xfrm>
+          <a:prstGeom prst="rect">
+            <a:avLst/>
+          </a:prstGeom>
+          <a:noFill/>
+          <a:ln w="12700" cap="flat">
+            <a:noFill/>
+            <a:miter lim="400000"/>
+          </a:ln>
+        </p:spPr>
+        <p:style>
+          <a:lnRef idx="0">
+            <a:srgbClr val="FFFFFF"/>
+          </a:lnRef>
+          <a:fillRef idx="0">
+            <a:srgbClr val="FFFFFF"/>
+          </a:fillRef>
+          <a:effectRef idx="0">
+            <a:srgbClr val="FFFFFF"/>
+          </a:effectRef>
+          <a:fontRef idx="none"/>
+        </p:style>
+        <p:txBody>
+          <a:bodyPr rot="0" vertOverflow="overflow" horzOverflow="overflow" vert="horz" wrap="square" lIns="0" tIns="0" rIns="0" bIns="0" numCol="1" spcCol="38100" rtlCol="0" anchor="t" forceAA="0" upright="0">
+            <a:spAutoFit/>
+          </a:bodyPr>
+          <a:p>
+            <a:pPr marL="0" marR="0" indent="0" algn="ctr" defTabSz="914400" rtl="0" fontAlgn="auto" latinLnBrk="0" hangingPunct="0">
+              <a:lnSpc>
+                <a:spcPct val="100000"/>
+              </a:lnSpc>
+              <a:spcBef>
+                <a:spcPts val="0"/>
+              </a:spcBef>
+              <a:spcAft>
+                <a:spcPts val="0"/>
+              </a:spcAft>
+              <a:buClrTx/>
+              <a:buSzTx/>
+              <a:buFontTx/>
+              <a:buNone/>
+            </a:pPr>
+            <a:r>
+              <a:rPr kumimoji="0" lang="zh-CN" altLang="en-US" sz="1800" b="0" i="0" u="none" strike="noStrike" cap="none" spc="0" normalizeH="0" baseline="0">
+                <a:ln>
+                  <a:noFill/>
+                </a:ln>
+                <a:solidFill>
+                  <a:srgbClr val="000000"/>
+                </a:solidFill>
+                <a:effectLst/>
+                <a:uFillTx/>
+                <a:latin typeface="+mj-lt"/>
+                <a:ea typeface="+mj-ea"/>
+                <a:cs typeface="+mj-cs"/>
+                <a:sym typeface="苹方-简" panose="020B0400000000000000" charset="-122"/>
+              </a:rPr>
+              <a:t>是否发生分支</a:t>
+            </a:r>
+            <a:r>
+              <a:rPr kumimoji="0" lang="en-US" altLang="zh-CN" sz="1800" b="0" i="0" u="none" strike="noStrike" cap="none" spc="0" normalizeH="0" baseline="0">
+                <a:ln>
+                  <a:noFill/>
+                </a:ln>
+                <a:solidFill>
+                  <a:srgbClr val="000000"/>
+                </a:solidFill>
+                <a:effectLst/>
+                <a:uFillTx/>
+                <a:latin typeface="Courier New Regular" panose="02070409020205090404" charset="0"/>
+                <a:ea typeface="+mj-ea"/>
+                <a:cs typeface="Courier New Regular" panose="02070409020205090404" charset="0"/>
+                <a:sym typeface="苹方-简" panose="020B0400000000000000" charset="-122"/>
+              </a:rPr>
+              <a:t>pc_</a:t>
+            </a:r>
+            <a:r>
+              <a:rPr kumimoji="0" lang="en-US" altLang="zh-CN" sz="1800" b="0" i="0" u="none" strike="noStrike" cap="none" spc="0" normalizeH="0" baseline="0">
+                <a:ln>
+                  <a:noFill/>
+                </a:ln>
+                <a:solidFill>
+                  <a:srgbClr val="000000"/>
+                </a:solidFill>
+                <a:effectLst/>
+                <a:uFillTx/>
+                <a:latin typeface="Courier New Regular" panose="02070409020205090404" charset="0"/>
+                <a:ea typeface="+mj-ea"/>
+                <a:cs typeface="Courier New Regular" panose="02070409020205090404" charset="0"/>
+                <a:sym typeface="苹方-简" panose="020B0400000000000000" charset="-122"/>
+              </a:rPr>
+              <a:t>take_branch_i</a:t>
+            </a:r>
+            <a:endParaRPr kumimoji="0" lang="en-US" altLang="zh-CN" sz="1800" b="0" i="0" u="none" strike="noStrike" cap="none" spc="0" normalizeH="0" baseline="0">
+              <a:ln>
+                <a:noFill/>
+              </a:ln>
+              <a:solidFill>
+                <a:srgbClr val="000000"/>
+              </a:solidFill>
+              <a:effectLst/>
+              <a:uFillTx/>
+              <a:latin typeface="Courier New Regular" panose="02070409020205090404" charset="0"/>
+              <a:ea typeface="+mj-ea"/>
+              <a:cs typeface="Courier New Regular" panose="02070409020205090404" charset="0"/>
+              <a:sym typeface="苹方-简" panose="020B0400000000000000" charset="-122"/>
+            </a:endParaRPr>
+          </a:p>
+        </p:txBody>
+      </p:sp>
+      <p:cxnSp>
+        <p:nvCxnSpPr>
+          <p:cNvPr id="8" name="直接箭头连接符 7"/>
+          <p:cNvCxnSpPr/>
+          <p:nvPr/>
+        </p:nvCxnSpPr>
+        <p:spPr>
+          <a:xfrm>
+            <a:off x="4617085" y="3285490"/>
+            <a:ext cx="864870" cy="15875"/>
+          </a:xfrm>
+          <a:prstGeom prst="straightConnector1">
+            <a:avLst/>
+          </a:prstGeom>
+          <a:noFill/>
+          <a:ln w="12700" cap="flat">
+            <a:solidFill>
+              <a:schemeClr val="accent1"/>
+            </a:solidFill>
+            <a:prstDash val="solid"/>
+            <a:miter lim="800000"/>
+            <a:tailEnd type="arrow"/>
+          </a:ln>
+          <a:effectLst>
+            <a:outerShdw blurRad="101600" dist="50800" dir="5400000" rotWithShape="0">
+              <a:schemeClr val="accent1">
+                <a:alpha val="60000"/>
+              </a:schemeClr>
+            </a:outerShdw>
+          </a:effectLst>
+        </p:spPr>
+        <p:style>
+          <a:lnRef idx="0">
+            <a:srgbClr val="FFFFFF"/>
+          </a:lnRef>
+          <a:fillRef idx="0">
+            <a:srgbClr val="FFFFFF"/>
+          </a:fillRef>
+          <a:effectRef idx="0">
+            <a:srgbClr val="FFFFFF"/>
+          </a:effectRef>
+          <a:fontRef idx="none"/>
+        </p:style>
+      </p:cxnSp>
+      <p:sp>
+        <p:nvSpPr>
+          <p:cNvPr id="9" name="文本框 8"/>
+          <p:cNvSpPr txBox="1"/>
+          <p:nvPr/>
+        </p:nvSpPr>
+        <p:spPr>
+          <a:xfrm>
+            <a:off x="2077085" y="2911475"/>
+            <a:ext cx="2540000" cy="830580"/>
+          </a:xfrm>
+          <a:prstGeom prst="rect">
+            <a:avLst/>
+          </a:prstGeom>
+          <a:noFill/>
+          <a:ln w="12700" cap="flat">
+            <a:noFill/>
+            <a:miter lim="400000"/>
+          </a:ln>
+        </p:spPr>
+        <p:style>
+          <a:lnRef idx="0">
+            <a:srgbClr val="FFFFFF"/>
+          </a:lnRef>
+          <a:fillRef idx="0">
+            <a:srgbClr val="FFFFFF"/>
+          </a:fillRef>
+          <a:effectRef idx="0">
+            <a:srgbClr val="FFFFFF"/>
+          </a:effectRef>
+          <a:fontRef idx="none"/>
+        </p:style>
+        <p:txBody>
+          <a:bodyPr rot="0" vertOverflow="overflow" horzOverflow="overflow" vert="horz" wrap="square" lIns="0" tIns="0" rIns="0" bIns="0" numCol="1" spcCol="38100" rtlCol="0" anchor="t" forceAA="0" upright="0">
+            <a:spAutoFit/>
+          </a:bodyPr>
+          <a:p>
+            <a:pPr marL="0" marR="0" indent="0" algn="ctr" defTabSz="914400" rtl="0" fontAlgn="auto" latinLnBrk="0" hangingPunct="0">
+              <a:lnSpc>
+                <a:spcPct val="100000"/>
+              </a:lnSpc>
+              <a:spcBef>
+                <a:spcPts val="0"/>
+              </a:spcBef>
+              <a:spcAft>
+                <a:spcPts val="0"/>
+              </a:spcAft>
+              <a:buClrTx/>
+              <a:buSzTx/>
+              <a:buFontTx/>
+              <a:buNone/>
+            </a:pPr>
+            <a:r>
+              <a:rPr kumimoji="0" lang="zh-CN" altLang="en-US" sz="1800" b="0" i="0" u="none" strike="noStrike" cap="none" spc="0" normalizeH="0" baseline="0">
+                <a:ln>
+                  <a:noFill/>
+                </a:ln>
+                <a:solidFill>
+                  <a:srgbClr val="000000"/>
+                </a:solidFill>
+                <a:effectLst/>
+                <a:uFillTx/>
+                <a:latin typeface="+mj-lt"/>
+                <a:ea typeface="+mj-ea"/>
+                <a:cs typeface="+mj-cs"/>
+                <a:sym typeface="苹方-简" panose="020B0400000000000000" charset="-122"/>
+              </a:rPr>
+              <a:t>允许取下一条指令</a:t>
+            </a:r>
+            <a:br>
+              <a:rPr kumimoji="0" lang="zh-CN" altLang="en-US" sz="1800" b="0" i="0" u="none" strike="noStrike" cap="none" spc="0" normalizeH="0" baseline="0">
+                <a:ln>
+                  <a:noFill/>
+                </a:ln>
+                <a:solidFill>
+                  <a:srgbClr val="000000"/>
+                </a:solidFill>
+                <a:effectLst/>
+                <a:uFillTx/>
+                <a:latin typeface="+mj-lt"/>
+                <a:ea typeface="+mj-ea"/>
+                <a:cs typeface="+mj-cs"/>
+                <a:sym typeface="苹方-简" panose="020B0400000000000000" charset="-122"/>
+              </a:rPr>
+            </a:br>
+            <a:r>
+              <a:rPr kumimoji="0" lang="en-US" altLang="zh-CN" sz="1800" b="0" i="0" u="none" strike="noStrike" cap="none" spc="0" normalizeH="0" baseline="0">
+                <a:ln>
+                  <a:noFill/>
+                </a:ln>
+                <a:solidFill>
+                  <a:schemeClr val="bg1">
+                    <a:lumMod val="65000"/>
+                  </a:schemeClr>
+                </a:solidFill>
+                <a:effectLst/>
+                <a:uFillTx/>
+                <a:latin typeface="+mj-lt"/>
+                <a:ea typeface="+mj-ea"/>
+                <a:cs typeface="+mj-cs"/>
+                <a:sym typeface="苹方-简" panose="020B0400000000000000" charset="-122"/>
+              </a:rPr>
+              <a:t>from PipelineCtrl</a:t>
+            </a:r>
+            <a:br>
+              <a:rPr kumimoji="0" lang="en-US" altLang="zh-CN" sz="1800" b="0" i="0" u="none" strike="noStrike" cap="none" spc="0" normalizeH="0" baseline="0">
+                <a:ln>
+                  <a:noFill/>
+                </a:ln>
+                <a:solidFill>
+                  <a:schemeClr val="bg1">
+                    <a:lumMod val="65000"/>
+                  </a:schemeClr>
+                </a:solidFill>
+                <a:effectLst/>
+                <a:uFillTx/>
+                <a:latin typeface="+mj-lt"/>
+                <a:ea typeface="+mj-ea"/>
+                <a:cs typeface="+mj-cs"/>
+                <a:sym typeface="苹方-简" panose="020B0400000000000000" charset="-122"/>
+              </a:rPr>
+            </a:br>
+            <a:r>
+              <a:rPr kumimoji="0" lang="en-US" altLang="zh-CN" sz="1800" b="0" i="0" u="none" strike="noStrike" cap="none" spc="0" normalizeH="0" baseline="0">
+                <a:ln>
+                  <a:noFill/>
+                </a:ln>
+                <a:solidFill>
+                  <a:srgbClr val="000000"/>
+                </a:solidFill>
+                <a:effectLst/>
+                <a:uFillTx/>
+                <a:latin typeface="Courier New Regular" panose="02070409020205090404" charset="0"/>
+                <a:ea typeface="+mj-ea"/>
+                <a:cs typeface="Courier New Regular" panose="02070409020205090404" charset="0"/>
+                <a:sym typeface="苹方-简" panose="020B0400000000000000" charset="-122"/>
+              </a:rPr>
+              <a:t>enable_i</a:t>
+            </a:r>
+            <a:endParaRPr kumimoji="0" lang="en-US" altLang="zh-CN" sz="1800" b="0" i="0" u="none" strike="noStrike" cap="none" spc="0" normalizeH="0" baseline="0">
+              <a:ln>
+                <a:noFill/>
+              </a:ln>
+              <a:solidFill>
+                <a:srgbClr val="000000"/>
+              </a:solidFill>
+              <a:effectLst/>
+              <a:uFillTx/>
+              <a:latin typeface="Courier New Regular" panose="02070409020205090404" charset="0"/>
+              <a:ea typeface="+mj-ea"/>
+              <a:cs typeface="Courier New Regular" panose="02070409020205090404" charset="0"/>
+              <a:sym typeface="苹方-简" panose="020B0400000000000000" charset="-122"/>
+            </a:endParaRPr>
+          </a:p>
+        </p:txBody>
+      </p:sp>
+      <p:cxnSp>
+        <p:nvCxnSpPr>
+          <p:cNvPr id="10" name="直接箭头连接符 9"/>
+          <p:cNvCxnSpPr/>
+          <p:nvPr/>
+        </p:nvCxnSpPr>
+        <p:spPr>
+          <a:xfrm>
+            <a:off x="4617085" y="4413885"/>
+            <a:ext cx="864870" cy="15875"/>
+          </a:xfrm>
+          <a:prstGeom prst="straightConnector1">
+            <a:avLst/>
+          </a:prstGeom>
+          <a:noFill/>
+          <a:ln w="12700" cap="flat">
+            <a:solidFill>
+              <a:schemeClr val="accent1"/>
+            </a:solidFill>
+            <a:prstDash val="solid"/>
+            <a:miter lim="800000"/>
+            <a:tailEnd type="arrow"/>
+          </a:ln>
+          <a:effectLst>
+            <a:outerShdw blurRad="101600" dist="50800" dir="5400000" rotWithShape="0">
+              <a:schemeClr val="accent1">
+                <a:alpha val="60000"/>
+              </a:schemeClr>
+            </a:outerShdw>
+          </a:effectLst>
+        </p:spPr>
+        <p:style>
+          <a:lnRef idx="0">
+            <a:srgbClr val="FFFFFF"/>
+          </a:lnRef>
+          <a:fillRef idx="0">
+            <a:srgbClr val="FFFFFF"/>
+          </a:fillRef>
+          <a:effectRef idx="0">
+            <a:srgbClr val="FFFFFF"/>
+          </a:effectRef>
+          <a:fontRef idx="none"/>
+        </p:style>
+      </p:cxnSp>
+      <p:sp>
+        <p:nvSpPr>
+          <p:cNvPr id="11" name="文本框 10"/>
+          <p:cNvSpPr txBox="1"/>
+          <p:nvPr/>
+        </p:nvSpPr>
+        <p:spPr>
+          <a:xfrm>
+            <a:off x="2077085" y="3956050"/>
+            <a:ext cx="2667635" cy="830580"/>
+          </a:xfrm>
+          <a:prstGeom prst="rect">
+            <a:avLst/>
+          </a:prstGeom>
+          <a:noFill/>
+          <a:ln w="12700" cap="flat">
+            <a:noFill/>
+            <a:miter lim="400000"/>
+          </a:ln>
+        </p:spPr>
+        <p:style>
+          <a:lnRef idx="0">
+            <a:srgbClr val="FFFFFF"/>
+          </a:lnRef>
+          <a:fillRef idx="0">
+            <a:srgbClr val="FFFFFF"/>
+          </a:fillRef>
+          <a:effectRef idx="0">
+            <a:srgbClr val="FFFFFF"/>
+          </a:effectRef>
+          <a:fontRef idx="none"/>
+        </p:style>
+        <p:txBody>
+          <a:bodyPr rot="0" vertOverflow="overflow" horzOverflow="overflow" vert="horz" wrap="square" lIns="0" tIns="0" rIns="0" bIns="0" numCol="1" spcCol="38100" rtlCol="0" anchor="t" forceAA="0" upright="0">
+            <a:spAutoFit/>
+          </a:bodyPr>
+          <a:p>
+            <a:pPr marL="0" marR="0" indent="0" algn="ctr" defTabSz="914400" rtl="0" fontAlgn="auto" latinLnBrk="0" hangingPunct="0">
+              <a:lnSpc>
+                <a:spcPct val="100000"/>
+              </a:lnSpc>
+              <a:spcBef>
+                <a:spcPts val="0"/>
+              </a:spcBef>
+              <a:spcAft>
+                <a:spcPts val="0"/>
+              </a:spcAft>
+              <a:buClrTx/>
+              <a:buSzTx/>
+              <a:buFontTx/>
+              <a:buNone/>
+            </a:pPr>
+            <a:r>
+              <a:rPr kumimoji="0" lang="zh-CN" altLang="en-US" sz="1800" b="0" i="0" u="none" strike="noStrike" cap="none" spc="0" normalizeH="0" baseline="0">
+                <a:ln>
+                  <a:noFill/>
+                </a:ln>
+                <a:solidFill>
+                  <a:srgbClr val="000000"/>
+                </a:solidFill>
+                <a:effectLst/>
+                <a:uFillTx/>
+                <a:latin typeface="+mj-lt"/>
+                <a:ea typeface="+mj-ea"/>
+                <a:cs typeface="+mj-cs"/>
+                <a:sym typeface="苹方-简" panose="020B0400000000000000" charset="-122"/>
+              </a:rPr>
+              <a:t>从内存读到的指令</a:t>
+            </a:r>
+            <a:br>
+              <a:rPr kumimoji="0" lang="zh-CN" altLang="en-US" sz="1800" b="0" i="0" u="none" strike="noStrike" cap="none" spc="0" normalizeH="0" baseline="0">
+                <a:ln>
+                  <a:noFill/>
+                </a:ln>
+                <a:solidFill>
+                  <a:srgbClr val="000000"/>
+                </a:solidFill>
+                <a:effectLst/>
+                <a:uFillTx/>
+                <a:latin typeface="+mj-lt"/>
+                <a:ea typeface="+mj-ea"/>
+                <a:cs typeface="+mj-cs"/>
+                <a:sym typeface="苹方-简" panose="020B0400000000000000" charset="-122"/>
+              </a:rPr>
+            </a:br>
+            <a:r>
+              <a:rPr kumimoji="0" lang="en-US" altLang="zh-CN" sz="1800" b="0" i="0" u="none" strike="noStrike" cap="none" spc="0" normalizeH="0" baseline="0">
+                <a:ln>
+                  <a:noFill/>
+                </a:ln>
+                <a:solidFill>
+                  <a:schemeClr val="bg1">
+                    <a:lumMod val="65000"/>
+                  </a:schemeClr>
+                </a:solidFill>
+                <a:effectLst/>
+                <a:uFillTx/>
+                <a:latin typeface="+mj-lt"/>
+                <a:ea typeface="+mj-ea"/>
+                <a:cs typeface="+mj-cs"/>
+                <a:sym typeface="苹方-简" panose="020B0400000000000000" charset="-122"/>
+              </a:rPr>
+              <a:t>from </a:t>
+            </a:r>
+            <a:r>
+              <a:rPr kumimoji="0" lang="zh-CN" altLang="en-US" sz="1800" b="0" i="0" u="none" strike="noStrike" cap="none" spc="0" normalizeH="0" baseline="0">
+                <a:ln>
+                  <a:noFill/>
+                </a:ln>
+                <a:solidFill>
+                  <a:schemeClr val="bg1">
+                    <a:lumMod val="65000"/>
+                  </a:schemeClr>
+                </a:solidFill>
+                <a:effectLst/>
+                <a:uFillTx/>
+                <a:latin typeface="+mj-lt"/>
+                <a:ea typeface="+mj-ea"/>
+                <a:cs typeface="+mj-cs"/>
+                <a:sym typeface="苹方-简" panose="020B0400000000000000" charset="-122"/>
+              </a:rPr>
+              <a:t>内存</a:t>
+            </a:r>
+            <a:br>
+              <a:rPr kumimoji="0" lang="zh-CN" altLang="en-US" sz="1800" b="0" i="0" u="none" strike="noStrike" cap="none" spc="0" normalizeH="0" baseline="0">
+                <a:ln>
+                  <a:noFill/>
+                </a:ln>
+                <a:solidFill>
+                  <a:srgbClr val="000000"/>
+                </a:solidFill>
+                <a:effectLst/>
+                <a:uFillTx/>
+                <a:latin typeface="+mj-lt"/>
+                <a:ea typeface="+mj-ea"/>
+                <a:cs typeface="+mj-cs"/>
+                <a:sym typeface="苹方-简" panose="020B0400000000000000" charset="-122"/>
+              </a:rPr>
+            </a:br>
+            <a:r>
+              <a:rPr kumimoji="0" lang="en-US" altLang="zh-CN" sz="1800" b="0" i="0" u="none" strike="noStrike" cap="none" spc="0" normalizeH="0" baseline="0">
+                <a:ln>
+                  <a:noFill/>
+                </a:ln>
+                <a:solidFill>
+                  <a:srgbClr val="000000"/>
+                </a:solidFill>
+                <a:effectLst/>
+                <a:uFillTx/>
+                <a:latin typeface="Courier New Regular" panose="02070409020205090404" charset="0"/>
+                <a:ea typeface="+mj-ea"/>
+                <a:cs typeface="Courier New Regular" panose="02070409020205090404" charset="0"/>
+                <a:sym typeface="苹方-简" panose="020B0400000000000000" charset="-122"/>
+              </a:rPr>
+              <a:t>mem_data_i</a:t>
+            </a:r>
+            <a:endParaRPr kumimoji="0" lang="en-US" altLang="zh-CN" sz="1800" b="0" i="0" u="none" strike="noStrike" cap="none" spc="0" normalizeH="0" baseline="0">
+              <a:ln>
+                <a:noFill/>
+              </a:ln>
+              <a:solidFill>
+                <a:srgbClr val="000000"/>
+              </a:solidFill>
+              <a:effectLst/>
+              <a:uFillTx/>
+              <a:latin typeface="Courier New Regular" panose="02070409020205090404" charset="0"/>
+              <a:ea typeface="+mj-ea"/>
+              <a:cs typeface="Courier New Regular" panose="02070409020205090404" charset="0"/>
+              <a:sym typeface="苹方-简" panose="020B0400000000000000" charset="-122"/>
+            </a:endParaRPr>
+          </a:p>
+        </p:txBody>
+      </p:sp>
+      <p:cxnSp>
+        <p:nvCxnSpPr>
+          <p:cNvPr id="12" name="直接箭头连接符 11"/>
+          <p:cNvCxnSpPr/>
+          <p:nvPr/>
+        </p:nvCxnSpPr>
+        <p:spPr>
+          <a:xfrm>
+            <a:off x="4617085" y="5517515"/>
+            <a:ext cx="864870" cy="15875"/>
+          </a:xfrm>
+          <a:prstGeom prst="straightConnector1">
+            <a:avLst/>
+          </a:prstGeom>
+          <a:noFill/>
+          <a:ln w="12700" cap="flat">
+            <a:solidFill>
+              <a:schemeClr val="accent1"/>
+            </a:solidFill>
+            <a:prstDash val="solid"/>
+            <a:miter lim="800000"/>
+            <a:tailEnd type="arrow"/>
+          </a:ln>
+          <a:effectLst>
+            <a:outerShdw blurRad="101600" dist="50800" dir="5400000" rotWithShape="0">
+              <a:schemeClr val="accent1">
+                <a:alpha val="60000"/>
+              </a:schemeClr>
+            </a:outerShdw>
+          </a:effectLst>
+        </p:spPr>
+        <p:style>
+          <a:lnRef idx="0">
+            <a:srgbClr val="FFFFFF"/>
+          </a:lnRef>
+          <a:fillRef idx="0">
+            <a:srgbClr val="FFFFFF"/>
+          </a:fillRef>
+          <a:effectRef idx="0">
+            <a:srgbClr val="FFFFFF"/>
+          </a:effectRef>
+          <a:fontRef idx="none"/>
+        </p:style>
+      </p:cxnSp>
+      <p:sp>
+        <p:nvSpPr>
+          <p:cNvPr id="13" name="文本框 12"/>
+          <p:cNvSpPr txBox="1"/>
+          <p:nvPr/>
+        </p:nvSpPr>
+        <p:spPr>
+          <a:xfrm>
+            <a:off x="2711450" y="5096510"/>
+            <a:ext cx="1684020" cy="830580"/>
+          </a:xfrm>
+          <a:prstGeom prst="rect">
+            <a:avLst/>
+          </a:prstGeom>
+          <a:noFill/>
+          <a:ln w="12700" cap="flat">
+            <a:noFill/>
+            <a:miter lim="400000"/>
+          </a:ln>
+        </p:spPr>
+        <p:style>
+          <a:lnRef idx="0">
+            <a:srgbClr val="FFFFFF"/>
+          </a:lnRef>
+          <a:fillRef idx="0">
+            <a:srgbClr val="FFFFFF"/>
+          </a:fillRef>
+          <a:effectRef idx="0">
+            <a:srgbClr val="FFFFFF"/>
+          </a:effectRef>
+          <a:fontRef idx="none"/>
+        </p:style>
+        <p:txBody>
+          <a:bodyPr rot="0" vertOverflow="overflow" horzOverflow="overflow" vert="horz" wrap="square" lIns="0" tIns="0" rIns="0" bIns="0" numCol="1" spcCol="38100" rtlCol="0" anchor="t" forceAA="0" upright="0">
+            <a:spAutoFit/>
+          </a:bodyPr>
+          <a:p>
+            <a:pPr marL="0" marR="0" indent="0" algn="ctr" defTabSz="914400" rtl="0" fontAlgn="auto" latinLnBrk="0" hangingPunct="0">
+              <a:lnSpc>
+                <a:spcPct val="100000"/>
+              </a:lnSpc>
+              <a:spcBef>
+                <a:spcPts val="0"/>
+              </a:spcBef>
+              <a:spcAft>
+                <a:spcPts val="0"/>
+              </a:spcAft>
+              <a:buClrTx/>
+              <a:buSzTx/>
+              <a:buFontTx/>
+              <a:buNone/>
+            </a:pPr>
+            <a:r>
+              <a:rPr kumimoji="0" lang="zh-CN" altLang="en-US" sz="1800" b="0" i="0" u="none" strike="noStrike" cap="none" spc="0" normalizeH="0" baseline="0">
+                <a:ln>
+                  <a:noFill/>
+                </a:ln>
+                <a:solidFill>
+                  <a:srgbClr val="000000"/>
+                </a:solidFill>
+                <a:effectLst/>
+                <a:uFillTx/>
+                <a:latin typeface="+mj-lt"/>
+                <a:ea typeface="+mj-ea"/>
+                <a:cs typeface="+mj-cs"/>
+                <a:sym typeface="苹方-简" panose="020B0400000000000000" charset="-122"/>
+              </a:rPr>
+              <a:t>内存操作完成</a:t>
+            </a:r>
+            <a:br>
+              <a:rPr kumimoji="0" lang="zh-CN" altLang="en-US" sz="1800" b="0" i="0" u="none" strike="noStrike" cap="none" spc="0" normalizeH="0" baseline="0">
+                <a:ln>
+                  <a:noFill/>
+                </a:ln>
+                <a:solidFill>
+                  <a:srgbClr val="000000"/>
+                </a:solidFill>
+                <a:effectLst/>
+                <a:uFillTx/>
+                <a:latin typeface="+mj-lt"/>
+                <a:ea typeface="+mj-ea"/>
+                <a:cs typeface="+mj-cs"/>
+                <a:sym typeface="苹方-简" panose="020B0400000000000000" charset="-122"/>
+              </a:rPr>
+            </a:br>
+            <a:r>
+              <a:rPr kumimoji="0" lang="en-US" altLang="zh-CN" sz="1800" b="0" i="0" u="none" strike="noStrike" cap="none" spc="0" normalizeH="0" baseline="0">
+                <a:ln>
+                  <a:noFill/>
+                </a:ln>
+                <a:solidFill>
+                  <a:schemeClr val="bg1">
+                    <a:lumMod val="65000"/>
+                  </a:schemeClr>
+                </a:solidFill>
+                <a:effectLst/>
+                <a:uFillTx/>
+                <a:latin typeface="+mj-lt"/>
+                <a:ea typeface="+mj-ea"/>
+                <a:cs typeface="+mj-cs"/>
+                <a:sym typeface="苹方-简" panose="020B0400000000000000" charset="-122"/>
+              </a:rPr>
+              <a:t>from </a:t>
+            </a:r>
+            <a:r>
+              <a:rPr kumimoji="0" lang="zh-CN" altLang="en-US" sz="1800" b="0" i="0" u="none" strike="noStrike" cap="none" spc="0" normalizeH="0" baseline="0">
+                <a:ln>
+                  <a:noFill/>
+                </a:ln>
+                <a:solidFill>
+                  <a:schemeClr val="bg1">
+                    <a:lumMod val="65000"/>
+                  </a:schemeClr>
+                </a:solidFill>
+                <a:effectLst/>
+                <a:uFillTx/>
+                <a:latin typeface="+mj-lt"/>
+                <a:ea typeface="+mj-ea"/>
+                <a:cs typeface="+mj-cs"/>
+                <a:sym typeface="苹方-简" panose="020B0400000000000000" charset="-122"/>
+              </a:rPr>
+              <a:t>内存</a:t>
+            </a:r>
+            <a:r>
+              <a:rPr kumimoji="0" lang="en-US" altLang="zh-CN" sz="1800" b="0" i="0" u="none" strike="noStrike" cap="none" spc="0" normalizeH="0" baseline="0">
+                <a:ln>
+                  <a:noFill/>
+                </a:ln>
+                <a:solidFill>
+                  <a:srgbClr val="000000"/>
+                </a:solidFill>
+                <a:effectLst/>
+                <a:uFillTx/>
+                <a:latin typeface="Courier New Regular" panose="02070409020205090404" charset="0"/>
+                <a:ea typeface="+mj-ea"/>
+                <a:cs typeface="Courier New Regular" panose="02070409020205090404" charset="0"/>
+                <a:sym typeface="苹方-简" panose="020B0400000000000000" charset="-122"/>
+              </a:rPr>
+              <a:t>mem_done_i</a:t>
+            </a:r>
+            <a:endParaRPr kumimoji="0" lang="en-US" altLang="zh-CN" sz="1800" b="0" i="0" u="none" strike="noStrike" cap="none" spc="0" normalizeH="0" baseline="0">
+              <a:ln>
+                <a:noFill/>
+              </a:ln>
+              <a:solidFill>
+                <a:srgbClr val="000000"/>
+              </a:solidFill>
+              <a:effectLst/>
+              <a:uFillTx/>
+              <a:latin typeface="Courier New Regular" panose="02070409020205090404" charset="0"/>
+              <a:ea typeface="+mj-ea"/>
+              <a:cs typeface="Courier New Regular" panose="02070409020205090404" charset="0"/>
+              <a:sym typeface="苹方-简" panose="020B0400000000000000" charset="-122"/>
+            </a:endParaRPr>
+          </a:p>
+        </p:txBody>
+      </p:sp>
+      <p:cxnSp>
+        <p:nvCxnSpPr>
+          <p:cNvPr id="16" name="直接箭头连接符 15"/>
+          <p:cNvCxnSpPr/>
+          <p:nvPr/>
+        </p:nvCxnSpPr>
+        <p:spPr>
+          <a:xfrm>
+            <a:off x="6383655" y="1181735"/>
+            <a:ext cx="864870" cy="15875"/>
+          </a:xfrm>
+          <a:prstGeom prst="straightConnector1">
+            <a:avLst/>
+          </a:prstGeom>
+          <a:noFill/>
+          <a:ln w="12700" cap="flat">
+            <a:solidFill>
+              <a:schemeClr val="accent1"/>
+            </a:solidFill>
+            <a:prstDash val="solid"/>
+            <a:miter lim="800000"/>
+            <a:tailEnd type="arrow"/>
+          </a:ln>
+          <a:effectLst>
+            <a:outerShdw blurRad="101600" dist="50800" dir="5400000" rotWithShape="0">
+              <a:schemeClr val="accent1">
+                <a:alpha val="60000"/>
+              </a:schemeClr>
+            </a:outerShdw>
+          </a:effectLst>
+        </p:spPr>
+        <p:style>
+          <a:lnRef idx="0">
+            <a:srgbClr val="FFFFFF"/>
+          </a:lnRef>
+          <a:fillRef idx="0">
+            <a:srgbClr val="FFFFFF"/>
+          </a:fillRef>
+          <a:effectRef idx="0">
+            <a:srgbClr val="FFFFFF"/>
+          </a:effectRef>
+          <a:fontRef idx="none"/>
+        </p:style>
+      </p:cxnSp>
+      <p:sp>
+        <p:nvSpPr>
+          <p:cNvPr id="17" name="文本框 16"/>
+          <p:cNvSpPr txBox="1"/>
+          <p:nvPr/>
+        </p:nvSpPr>
+        <p:spPr>
+          <a:xfrm>
+            <a:off x="7470775" y="774700"/>
+            <a:ext cx="1379220" cy="830580"/>
+          </a:xfrm>
+          <a:prstGeom prst="rect">
+            <a:avLst/>
+          </a:prstGeom>
+          <a:noFill/>
+          <a:ln w="12700" cap="flat">
+            <a:noFill/>
+            <a:miter lim="400000"/>
+          </a:ln>
+        </p:spPr>
+        <p:style>
+          <a:lnRef idx="0">
+            <a:srgbClr val="FFFFFF"/>
+          </a:lnRef>
+          <a:fillRef idx="0">
+            <a:srgbClr val="FFFFFF"/>
+          </a:fillRef>
+          <a:effectRef idx="0">
+            <a:srgbClr val="FFFFFF"/>
+          </a:effectRef>
+          <a:fontRef idx="none"/>
+        </p:style>
+        <p:txBody>
+          <a:bodyPr rot="0" vertOverflow="overflow" horzOverflow="overflow" vert="horz" wrap="square" lIns="0" tIns="0" rIns="0" bIns="0" numCol="1" spcCol="38100" rtlCol="0" anchor="t" forceAA="0" upright="0">
+            <a:spAutoFit/>
+          </a:bodyPr>
+          <a:p>
+            <a:pPr marL="0" marR="0" indent="0" algn="ctr" defTabSz="914400" rtl="0" fontAlgn="auto" latinLnBrk="0" hangingPunct="0">
+              <a:lnSpc>
+                <a:spcPct val="100000"/>
+              </a:lnSpc>
+              <a:spcBef>
+                <a:spcPts val="0"/>
+              </a:spcBef>
+              <a:spcAft>
+                <a:spcPts val="0"/>
+              </a:spcAft>
+              <a:buClrTx/>
+              <a:buSzTx/>
+              <a:buFontTx/>
+              <a:buNone/>
+            </a:pPr>
+            <a:r>
+              <a:rPr kumimoji="0" lang="zh-CN" altLang="en-US" sz="1800" b="0" i="0" u="none" strike="noStrike" cap="none" spc="0" normalizeH="0" baseline="0">
+                <a:ln>
+                  <a:noFill/>
+                </a:ln>
+                <a:solidFill>
+                  <a:srgbClr val="000000"/>
+                </a:solidFill>
+                <a:effectLst/>
+                <a:uFillTx/>
+                <a:latin typeface="+mj-lt"/>
+                <a:ea typeface="+mj-ea"/>
+                <a:cs typeface="+mj-cs"/>
+                <a:sym typeface="苹方-简" panose="020B0400000000000000" charset="-122"/>
+              </a:rPr>
+              <a:t>当前指令</a:t>
+            </a:r>
+            <a:r>
+              <a:rPr kumimoji="0" lang="en-US" altLang="zh-CN" sz="1800" b="0" i="0" u="none" strike="noStrike" cap="none" spc="0" normalizeH="0" baseline="0">
+                <a:ln>
+                  <a:noFill/>
+                </a:ln>
+                <a:solidFill>
+                  <a:srgbClr val="000000"/>
+                </a:solidFill>
+                <a:effectLst/>
+                <a:uFillTx/>
+                <a:latin typeface="Courier New Regular" panose="02070409020205090404" charset="0"/>
+                <a:ea typeface="+mj-ea"/>
+                <a:cs typeface="Courier New Regular" panose="02070409020205090404" charset="0"/>
+                <a:sym typeface="苹方-简" panose="020B0400000000000000" charset="-122"/>
+              </a:rPr>
+              <a:t>PC</a:t>
+            </a:r>
+            <a:br>
+              <a:rPr kumimoji="0" lang="en-US" altLang="zh-CN" sz="1800" b="0" i="0" u="none" strike="noStrike" cap="none" spc="0" normalizeH="0" baseline="0">
+                <a:ln>
+                  <a:noFill/>
+                </a:ln>
+                <a:solidFill>
+                  <a:srgbClr val="000000"/>
+                </a:solidFill>
+                <a:effectLst/>
+                <a:uFillTx/>
+                <a:latin typeface="Courier New Regular" panose="02070409020205090404" charset="0"/>
+                <a:ea typeface="+mj-ea"/>
+                <a:cs typeface="Courier New Regular" panose="02070409020205090404" charset="0"/>
+                <a:sym typeface="苹方-简" panose="020B0400000000000000" charset="-122"/>
+              </a:rPr>
+            </a:br>
+            <a:r>
+              <a:rPr kumimoji="0" lang="en-US" altLang="zh-CN" sz="1800" b="0" i="0" u="none" strike="noStrike" cap="none" spc="0" normalizeH="0" baseline="0">
+                <a:ln>
+                  <a:noFill/>
+                </a:ln>
+                <a:solidFill>
+                  <a:schemeClr val="bg1">
+                    <a:lumMod val="65000"/>
+                  </a:schemeClr>
+                </a:solidFill>
+                <a:effectLst/>
+                <a:uFillTx/>
+                <a:latin typeface="+mn-lt"/>
+                <a:ea typeface="+mj-ea"/>
+                <a:cs typeface="+mn-lt"/>
+                <a:sym typeface="苹方-简" panose="020B0400000000000000" charset="-122"/>
+              </a:rPr>
+              <a:t>to </a:t>
+            </a:r>
+            <a:endParaRPr kumimoji="0" lang="en-US" altLang="zh-CN" sz="1800" b="0" i="0" u="none" strike="noStrike" cap="none" spc="0" normalizeH="0" baseline="0">
+              <a:ln>
+                <a:noFill/>
+              </a:ln>
+              <a:solidFill>
+                <a:srgbClr val="000000"/>
+              </a:solidFill>
+              <a:effectLst/>
+              <a:uFillTx/>
+              <a:latin typeface="+mj-lt"/>
+              <a:ea typeface="+mj-ea"/>
+              <a:cs typeface="+mj-cs"/>
+              <a:sym typeface="苹方-简" panose="020B0400000000000000" charset="-122"/>
+            </a:endParaRPr>
+          </a:p>
+          <a:p>
+            <a:pPr marL="0" marR="0" indent="0" algn="ctr" defTabSz="914400" rtl="0" fontAlgn="auto" latinLnBrk="0" hangingPunct="0">
+              <a:lnSpc>
+                <a:spcPct val="100000"/>
+              </a:lnSpc>
+              <a:spcBef>
+                <a:spcPts val="0"/>
+              </a:spcBef>
+              <a:spcAft>
+                <a:spcPts val="0"/>
+              </a:spcAft>
+              <a:buClrTx/>
+              <a:buSzTx/>
+              <a:buFontTx/>
+              <a:buNone/>
+            </a:pPr>
+            <a:r>
+              <a:rPr kumimoji="0" lang="en-US" altLang="zh-CN" sz="1800" b="0" i="0" u="none" strike="noStrike" cap="none" spc="0" normalizeH="0" baseline="0">
+                <a:ln>
+                  <a:noFill/>
+                </a:ln>
+                <a:solidFill>
+                  <a:srgbClr val="000000"/>
+                </a:solidFill>
+                <a:effectLst/>
+                <a:uFillTx/>
+                <a:latin typeface="Courier New Regular" panose="02070409020205090404" charset="0"/>
+                <a:ea typeface="+mj-ea"/>
+                <a:cs typeface="Courier New Regular" panose="02070409020205090404" charset="0"/>
+                <a:sym typeface="苹方-简" panose="020B0400000000000000" charset="-122"/>
+              </a:rPr>
+              <a:t>pc_o</a:t>
+            </a:r>
+            <a:endParaRPr kumimoji="0" lang="en-US" altLang="zh-CN" sz="1800" b="0" i="0" u="none" strike="noStrike" cap="none" spc="0" normalizeH="0" baseline="0">
+              <a:ln>
+                <a:noFill/>
+              </a:ln>
+              <a:solidFill>
+                <a:srgbClr val="000000"/>
+              </a:solidFill>
+              <a:effectLst/>
+              <a:uFillTx/>
+              <a:latin typeface="Courier New Regular" panose="02070409020205090404" charset="0"/>
+              <a:ea typeface="+mj-ea"/>
+              <a:cs typeface="Courier New Regular" panose="02070409020205090404" charset="0"/>
+              <a:sym typeface="苹方-简" panose="020B0400000000000000" charset="-122"/>
+            </a:endParaRPr>
+          </a:p>
+        </p:txBody>
+      </p:sp>
+      <p:cxnSp>
+        <p:nvCxnSpPr>
+          <p:cNvPr id="18" name="直接箭头连接符 17"/>
+          <p:cNvCxnSpPr/>
+          <p:nvPr/>
+        </p:nvCxnSpPr>
+        <p:spPr>
+          <a:xfrm>
+            <a:off x="6383655" y="2251710"/>
+            <a:ext cx="864870" cy="15875"/>
+          </a:xfrm>
+          <a:prstGeom prst="straightConnector1">
+            <a:avLst/>
+          </a:prstGeom>
+          <a:noFill/>
+          <a:ln w="12700" cap="flat">
+            <a:solidFill>
+              <a:schemeClr val="accent1"/>
+            </a:solidFill>
+            <a:prstDash val="solid"/>
+            <a:miter lim="800000"/>
+            <a:tailEnd type="arrow"/>
+          </a:ln>
+          <a:effectLst>
+            <a:outerShdw blurRad="101600" dist="50800" dir="5400000" rotWithShape="0">
+              <a:schemeClr val="accent1">
+                <a:alpha val="60000"/>
+              </a:schemeClr>
+            </a:outerShdw>
+          </a:effectLst>
+        </p:spPr>
+        <p:style>
+          <a:lnRef idx="0">
+            <a:srgbClr val="FFFFFF"/>
+          </a:lnRef>
+          <a:fillRef idx="0">
+            <a:srgbClr val="FFFFFF"/>
+          </a:fillRef>
+          <a:effectRef idx="0">
+            <a:srgbClr val="FFFFFF"/>
+          </a:effectRef>
+          <a:fontRef idx="none"/>
+        </p:style>
+      </p:cxnSp>
+      <p:sp>
+        <p:nvSpPr>
+          <p:cNvPr id="19" name="文本框 18"/>
+          <p:cNvSpPr txBox="1"/>
+          <p:nvPr/>
+        </p:nvSpPr>
+        <p:spPr>
+          <a:xfrm>
+            <a:off x="7292975" y="1864360"/>
+            <a:ext cx="1869440" cy="830580"/>
+          </a:xfrm>
+          <a:prstGeom prst="rect">
+            <a:avLst/>
+          </a:prstGeom>
+          <a:noFill/>
+          <a:ln w="12700" cap="flat">
+            <a:noFill/>
+            <a:miter lim="400000"/>
+          </a:ln>
+        </p:spPr>
+        <p:style>
+          <a:lnRef idx="0">
+            <a:srgbClr val="FFFFFF"/>
+          </a:lnRef>
+          <a:fillRef idx="0">
+            <a:srgbClr val="FFFFFF"/>
+          </a:fillRef>
+          <a:effectRef idx="0">
+            <a:srgbClr val="FFFFFF"/>
+          </a:effectRef>
+          <a:fontRef idx="none"/>
+        </p:style>
+        <p:txBody>
+          <a:bodyPr rot="0" vertOverflow="overflow" horzOverflow="overflow" vert="horz" wrap="square" lIns="0" tIns="0" rIns="0" bIns="0" numCol="1" spcCol="38100" rtlCol="0" anchor="t" forceAA="0" upright="0">
+            <a:spAutoFit/>
+          </a:bodyPr>
+          <a:p>
+            <a:pPr marL="0" marR="0" indent="0" algn="ctr" defTabSz="914400" rtl="0" fontAlgn="auto" latinLnBrk="0" hangingPunct="0">
+              <a:lnSpc>
+                <a:spcPct val="100000"/>
+              </a:lnSpc>
+              <a:spcBef>
+                <a:spcPts val="0"/>
+              </a:spcBef>
+              <a:spcAft>
+                <a:spcPts val="0"/>
+              </a:spcAft>
+              <a:buClrTx/>
+              <a:buSzTx/>
+              <a:buFontTx/>
+              <a:buNone/>
+            </a:pPr>
+            <a:r>
+              <a:rPr kumimoji="0" lang="zh-CN" altLang="en-US" sz="1800" b="0" i="0" u="none" strike="noStrike" cap="none" spc="0" normalizeH="0" baseline="0">
+                <a:ln>
+                  <a:noFill/>
+                </a:ln>
+                <a:solidFill>
+                  <a:srgbClr val="000000"/>
+                </a:solidFill>
+                <a:effectLst/>
+                <a:uFillTx/>
+                <a:latin typeface="+mj-lt"/>
+                <a:ea typeface="+mj-ea"/>
+                <a:cs typeface="+mj-cs"/>
+                <a:sym typeface="苹方-简" panose="020B0400000000000000" charset="-122"/>
+              </a:rPr>
+              <a:t>取到的指令</a:t>
+            </a:r>
+            <a:endParaRPr kumimoji="0" lang="zh-CN" altLang="en-US" sz="1800" b="0" i="0" u="none" strike="noStrike" cap="none" spc="0" normalizeH="0" baseline="0">
+              <a:ln>
+                <a:noFill/>
+              </a:ln>
+              <a:solidFill>
+                <a:srgbClr val="000000"/>
+              </a:solidFill>
+              <a:effectLst/>
+              <a:uFillTx/>
+              <a:latin typeface="+mj-lt"/>
+              <a:ea typeface="+mj-ea"/>
+              <a:cs typeface="+mj-cs"/>
+              <a:sym typeface="苹方-简" panose="020B0400000000000000" charset="-122"/>
+            </a:endParaRPr>
+          </a:p>
+          <a:p>
+            <a:pPr marL="0" marR="0" indent="0" algn="ctr" defTabSz="914400" rtl="0" fontAlgn="auto" latinLnBrk="0" hangingPunct="0">
+              <a:lnSpc>
+                <a:spcPct val="100000"/>
+              </a:lnSpc>
+              <a:spcBef>
+                <a:spcPts val="0"/>
+              </a:spcBef>
+              <a:spcAft>
+                <a:spcPts val="0"/>
+              </a:spcAft>
+              <a:buClrTx/>
+              <a:buSzTx/>
+              <a:buFontTx/>
+              <a:buNone/>
+            </a:pPr>
+            <a:r>
+              <a:rPr kumimoji="0" lang="en-US" altLang="zh-CN" sz="1800" b="0" i="0" u="none" strike="noStrike" cap="none" spc="0" normalizeH="0" baseline="0">
+                <a:ln>
+                  <a:noFill/>
+                </a:ln>
+                <a:solidFill>
+                  <a:schemeClr val="bg1">
+                    <a:lumMod val="65000"/>
+                  </a:schemeClr>
+                </a:solidFill>
+                <a:effectLst/>
+                <a:uFillTx/>
+                <a:latin typeface="+mj-lt"/>
+                <a:ea typeface="+mj-ea"/>
+                <a:cs typeface="+mj-cs"/>
+                <a:sym typeface="苹方-简" panose="020B0400000000000000" charset="-122"/>
+              </a:rPr>
+              <a:t>to ID</a:t>
+            </a:r>
+            <a:br>
+              <a:rPr kumimoji="0" lang="zh-CN" altLang="en-US" sz="1800" b="0" i="0" u="none" strike="noStrike" cap="none" spc="0" normalizeH="0" baseline="0">
+                <a:ln>
+                  <a:noFill/>
+                </a:ln>
+                <a:solidFill>
+                  <a:srgbClr val="000000"/>
+                </a:solidFill>
+                <a:effectLst/>
+                <a:uFillTx/>
+                <a:latin typeface="+mj-lt"/>
+                <a:ea typeface="+mj-ea"/>
+                <a:cs typeface="+mj-cs"/>
+                <a:sym typeface="苹方-简" panose="020B0400000000000000" charset="-122"/>
+              </a:rPr>
+            </a:br>
+            <a:r>
+              <a:rPr kumimoji="0" lang="en-US" altLang="zh-CN" sz="1800" b="0" i="0" u="none" strike="noStrike" cap="none" spc="0" normalizeH="0" baseline="0">
+                <a:ln>
+                  <a:noFill/>
+                </a:ln>
+                <a:solidFill>
+                  <a:srgbClr val="000000"/>
+                </a:solidFill>
+                <a:effectLst/>
+                <a:uFillTx/>
+                <a:latin typeface="Courier New Regular" panose="02070409020205090404" charset="0"/>
+                <a:ea typeface="+mj-ea"/>
+                <a:cs typeface="Courier New Regular" panose="02070409020205090404" charset="0"/>
+                <a:sym typeface="苹方-简" panose="020B0400000000000000" charset="-122"/>
+              </a:rPr>
+              <a:t>inst_o</a:t>
+            </a:r>
+            <a:endParaRPr kumimoji="0" lang="en-US" altLang="zh-CN" sz="1800" b="0" i="0" u="none" strike="noStrike" cap="none" spc="0" normalizeH="0" baseline="0">
+              <a:ln>
+                <a:noFill/>
+              </a:ln>
+              <a:solidFill>
+                <a:srgbClr val="000000"/>
+              </a:solidFill>
+              <a:effectLst/>
+              <a:uFillTx/>
+              <a:latin typeface="Courier New Regular" panose="02070409020205090404" charset="0"/>
+              <a:ea typeface="+mj-ea"/>
+              <a:cs typeface="Courier New Regular" panose="02070409020205090404" charset="0"/>
+              <a:sym typeface="苹方-简" panose="020B0400000000000000" charset="-122"/>
+            </a:endParaRPr>
+          </a:p>
+        </p:txBody>
+      </p:sp>
+      <p:cxnSp>
+        <p:nvCxnSpPr>
+          <p:cNvPr id="20" name="直接箭头连接符 19"/>
+          <p:cNvCxnSpPr/>
+          <p:nvPr/>
+        </p:nvCxnSpPr>
+        <p:spPr>
+          <a:xfrm>
+            <a:off x="6395720" y="3299460"/>
+            <a:ext cx="864870" cy="15875"/>
+          </a:xfrm>
+          <a:prstGeom prst="straightConnector1">
+            <a:avLst/>
+          </a:prstGeom>
+          <a:noFill/>
+          <a:ln w="12700" cap="flat">
+            <a:solidFill>
+              <a:schemeClr val="accent1"/>
+            </a:solidFill>
+            <a:prstDash val="solid"/>
+            <a:miter lim="800000"/>
+            <a:tailEnd type="arrow"/>
+          </a:ln>
+          <a:effectLst>
+            <a:outerShdw blurRad="101600" dist="50800" dir="5400000" rotWithShape="0">
+              <a:schemeClr val="accent1">
+                <a:alpha val="60000"/>
+              </a:schemeClr>
+            </a:outerShdw>
+          </a:effectLst>
+        </p:spPr>
+        <p:style>
+          <a:lnRef idx="0">
+            <a:srgbClr val="FFFFFF"/>
+          </a:lnRef>
+          <a:fillRef idx="0">
+            <a:srgbClr val="FFFFFF"/>
+          </a:fillRef>
+          <a:effectRef idx="0">
+            <a:srgbClr val="FFFFFF"/>
+          </a:effectRef>
+          <a:fontRef idx="none"/>
+        </p:style>
+      </p:cxnSp>
+      <p:sp>
+        <p:nvSpPr>
+          <p:cNvPr id="21" name="文本框 20"/>
+          <p:cNvSpPr txBox="1"/>
+          <p:nvPr/>
+        </p:nvSpPr>
+        <p:spPr>
+          <a:xfrm>
+            <a:off x="7320280" y="2954020"/>
+            <a:ext cx="1869440" cy="830580"/>
+          </a:xfrm>
+          <a:prstGeom prst="rect">
+            <a:avLst/>
+          </a:prstGeom>
+          <a:noFill/>
+          <a:ln w="12700" cap="flat">
+            <a:noFill/>
+            <a:miter lim="400000"/>
+          </a:ln>
+        </p:spPr>
+        <p:style>
+          <a:lnRef idx="0">
+            <a:srgbClr val="FFFFFF"/>
+          </a:lnRef>
+          <a:fillRef idx="0">
+            <a:srgbClr val="FFFFFF"/>
+          </a:fillRef>
+          <a:effectRef idx="0">
+            <a:srgbClr val="FFFFFF"/>
+          </a:effectRef>
+          <a:fontRef idx="none"/>
+        </p:style>
+        <p:txBody>
+          <a:bodyPr rot="0" vertOverflow="overflow" horzOverflow="overflow" vert="horz" wrap="square" lIns="0" tIns="0" rIns="0" bIns="0" numCol="1" spcCol="38100" rtlCol="0" anchor="t" forceAA="0" upright="0">
+            <a:spAutoFit/>
+          </a:bodyPr>
+          <a:p>
+            <a:pPr marL="0" marR="0" indent="0" algn="ctr" defTabSz="914400" rtl="0" fontAlgn="auto" latinLnBrk="0" hangingPunct="0">
+              <a:lnSpc>
+                <a:spcPct val="100000"/>
+              </a:lnSpc>
+              <a:spcBef>
+                <a:spcPts val="0"/>
+              </a:spcBef>
+              <a:spcAft>
+                <a:spcPts val="0"/>
+              </a:spcAft>
+              <a:buClrTx/>
+              <a:buSzTx/>
+              <a:buFontTx/>
+              <a:buNone/>
+            </a:pPr>
+            <a:r>
+              <a:rPr kumimoji="0" lang="zh-CN" altLang="en-US" sz="1800" b="0" i="0" u="none" strike="noStrike" cap="none" spc="0" normalizeH="0" baseline="0">
+                <a:ln>
+                  <a:noFill/>
+                </a:ln>
+                <a:solidFill>
+                  <a:srgbClr val="000000"/>
+                </a:solidFill>
+                <a:effectLst/>
+                <a:uFillTx/>
+                <a:latin typeface="+mj-lt"/>
+                <a:ea typeface="+mj-ea"/>
+                <a:cs typeface="+mj-cs"/>
+                <a:sym typeface="苹方-简" panose="020B0400000000000000" charset="-122"/>
+              </a:rPr>
+              <a:t>要读取内存的地址</a:t>
+            </a:r>
+            <a:br>
+              <a:rPr kumimoji="0" lang="zh-CN" altLang="en-US" sz="1800" b="0" i="0" u="none" strike="noStrike" cap="none" spc="0" normalizeH="0" baseline="0">
+                <a:ln>
+                  <a:noFill/>
+                </a:ln>
+                <a:solidFill>
+                  <a:srgbClr val="000000"/>
+                </a:solidFill>
+                <a:effectLst/>
+                <a:uFillTx/>
+                <a:latin typeface="+mj-lt"/>
+                <a:ea typeface="+mj-ea"/>
+                <a:cs typeface="+mj-cs"/>
+                <a:sym typeface="苹方-简" panose="020B0400000000000000" charset="-122"/>
+              </a:rPr>
+            </a:br>
+            <a:r>
+              <a:rPr kumimoji="0" lang="en-US" altLang="zh-CN" sz="1800" b="0" i="0" u="none" strike="noStrike" cap="none" spc="0" normalizeH="0" baseline="0">
+                <a:ln>
+                  <a:noFill/>
+                </a:ln>
+                <a:solidFill>
+                  <a:schemeClr val="bg1">
+                    <a:lumMod val="65000"/>
+                  </a:schemeClr>
+                </a:solidFill>
+                <a:effectLst/>
+                <a:uFillTx/>
+                <a:latin typeface="+mj-lt"/>
+                <a:ea typeface="+mj-ea"/>
+                <a:cs typeface="+mj-cs"/>
+                <a:sym typeface="苹方-简" panose="020B0400000000000000" charset="-122"/>
+              </a:rPr>
+              <a:t>to </a:t>
+            </a:r>
+            <a:r>
+              <a:rPr kumimoji="0" lang="zh-CN" altLang="en-US" sz="1800" b="0" i="0" u="none" strike="noStrike" cap="none" spc="0" normalizeH="0" baseline="0">
+                <a:ln>
+                  <a:noFill/>
+                </a:ln>
+                <a:solidFill>
+                  <a:schemeClr val="bg1">
+                    <a:lumMod val="65000"/>
+                  </a:schemeClr>
+                </a:solidFill>
+                <a:effectLst/>
+                <a:uFillTx/>
+                <a:latin typeface="+mj-lt"/>
+                <a:ea typeface="+mj-ea"/>
+                <a:cs typeface="+mj-cs"/>
+                <a:sym typeface="苹方-简" panose="020B0400000000000000" charset="-122"/>
+              </a:rPr>
+              <a:t>内存</a:t>
+            </a:r>
+            <a:br>
+              <a:rPr kumimoji="0" lang="zh-CN" altLang="en-US" sz="1800" b="0" i="0" u="none" strike="noStrike" cap="none" spc="0" normalizeH="0" baseline="0">
+                <a:ln>
+                  <a:noFill/>
+                </a:ln>
+                <a:solidFill>
+                  <a:srgbClr val="000000"/>
+                </a:solidFill>
+                <a:effectLst/>
+                <a:uFillTx/>
+                <a:latin typeface="+mj-lt"/>
+                <a:ea typeface="+mj-ea"/>
+                <a:cs typeface="+mj-cs"/>
+                <a:sym typeface="苹方-简" panose="020B0400000000000000" charset="-122"/>
+              </a:rPr>
+            </a:br>
+            <a:r>
+              <a:rPr kumimoji="0" lang="en-US" altLang="zh-CN" sz="1800" b="0" i="0" u="none" strike="noStrike" cap="none" spc="0" normalizeH="0" baseline="0">
+                <a:ln>
+                  <a:noFill/>
+                </a:ln>
+                <a:solidFill>
+                  <a:srgbClr val="000000"/>
+                </a:solidFill>
+                <a:effectLst/>
+                <a:uFillTx/>
+                <a:latin typeface="Courier New Regular" panose="02070409020205090404" charset="0"/>
+                <a:ea typeface="+mj-ea"/>
+                <a:cs typeface="Courier New Regular" panose="02070409020205090404" charset="0"/>
+                <a:sym typeface="苹方-简" panose="020B0400000000000000" charset="-122"/>
+              </a:rPr>
+              <a:t>mem_addr_o</a:t>
+            </a:r>
+            <a:endParaRPr kumimoji="0" lang="en-US" altLang="zh-CN" sz="1800" b="0" i="0" u="none" strike="noStrike" cap="none" spc="0" normalizeH="0" baseline="0">
+              <a:ln>
+                <a:noFill/>
+              </a:ln>
+              <a:solidFill>
+                <a:srgbClr val="000000"/>
+              </a:solidFill>
+              <a:effectLst/>
+              <a:uFillTx/>
+              <a:latin typeface="Courier New Regular" panose="02070409020205090404" charset="0"/>
+              <a:ea typeface="+mj-ea"/>
+              <a:cs typeface="Courier New Regular" panose="02070409020205090404" charset="0"/>
+              <a:sym typeface="苹方-简" panose="020B0400000000000000" charset="-122"/>
+            </a:endParaRPr>
+          </a:p>
+        </p:txBody>
+      </p:sp>
+      <p:cxnSp>
+        <p:nvCxnSpPr>
+          <p:cNvPr id="22" name="直接箭头连接符 21"/>
+          <p:cNvCxnSpPr/>
+          <p:nvPr/>
+        </p:nvCxnSpPr>
+        <p:spPr>
+          <a:xfrm>
+            <a:off x="6403975" y="4459605"/>
+            <a:ext cx="864870" cy="15875"/>
+          </a:xfrm>
+          <a:prstGeom prst="straightConnector1">
+            <a:avLst/>
+          </a:prstGeom>
+          <a:noFill/>
+          <a:ln w="12700" cap="flat">
+            <a:solidFill>
+              <a:schemeClr val="accent1"/>
+            </a:solidFill>
+            <a:prstDash val="solid"/>
+            <a:miter lim="800000"/>
+            <a:tailEnd type="arrow"/>
+          </a:ln>
+          <a:effectLst>
+            <a:outerShdw blurRad="101600" dist="50800" dir="5400000" rotWithShape="0">
+              <a:schemeClr val="accent1">
+                <a:alpha val="60000"/>
+              </a:schemeClr>
+            </a:outerShdw>
+          </a:effectLst>
+        </p:spPr>
+        <p:style>
+          <a:lnRef idx="0">
+            <a:srgbClr val="FFFFFF"/>
+          </a:lnRef>
+          <a:fillRef idx="0">
+            <a:srgbClr val="FFFFFF"/>
+          </a:fillRef>
+          <a:effectRef idx="0">
+            <a:srgbClr val="FFFFFF"/>
+          </a:effectRef>
+          <a:fontRef idx="none"/>
+        </p:style>
+      </p:cxnSp>
+      <p:sp>
+        <p:nvSpPr>
+          <p:cNvPr id="23" name="文本框 22"/>
+          <p:cNvSpPr txBox="1"/>
+          <p:nvPr/>
+        </p:nvSpPr>
+        <p:spPr>
+          <a:xfrm>
+            <a:off x="7392035" y="4130040"/>
+            <a:ext cx="1869440" cy="830580"/>
+          </a:xfrm>
+          <a:prstGeom prst="rect">
+            <a:avLst/>
+          </a:prstGeom>
+          <a:noFill/>
+          <a:ln w="12700" cap="flat">
+            <a:noFill/>
+            <a:miter lim="400000"/>
+          </a:ln>
+        </p:spPr>
+        <p:style>
+          <a:lnRef idx="0">
+            <a:srgbClr val="FFFFFF"/>
+          </a:lnRef>
+          <a:fillRef idx="0">
+            <a:srgbClr val="FFFFFF"/>
+          </a:fillRef>
+          <a:effectRef idx="0">
+            <a:srgbClr val="FFFFFF"/>
+          </a:effectRef>
+          <a:fontRef idx="none"/>
+        </p:style>
+        <p:txBody>
+          <a:bodyPr rot="0" vertOverflow="overflow" horzOverflow="overflow" vert="horz" wrap="square" lIns="0" tIns="0" rIns="0" bIns="0" numCol="1" spcCol="38100" rtlCol="0" anchor="t" forceAA="0" upright="0">
+            <a:spAutoFit/>
+          </a:bodyPr>
+          <a:p>
+            <a:pPr marL="0" marR="0" indent="0" algn="ctr" defTabSz="914400" rtl="0" fontAlgn="auto" latinLnBrk="0" hangingPunct="0">
+              <a:lnSpc>
+                <a:spcPct val="100000"/>
+              </a:lnSpc>
+              <a:spcBef>
+                <a:spcPts val="0"/>
+              </a:spcBef>
+              <a:spcAft>
+                <a:spcPts val="0"/>
+              </a:spcAft>
+              <a:buClrTx/>
+              <a:buSzTx/>
+              <a:buFontTx/>
+              <a:buNone/>
+            </a:pPr>
+            <a:r>
+              <a:rPr kumimoji="0" lang="zh-CN" altLang="en-US" sz="1800" b="0" i="0" u="none" strike="noStrike" cap="none" spc="0" normalizeH="0" baseline="0">
+                <a:ln>
+                  <a:noFill/>
+                </a:ln>
+                <a:solidFill>
+                  <a:srgbClr val="000000"/>
+                </a:solidFill>
+                <a:effectLst/>
+                <a:uFillTx/>
+                <a:latin typeface="+mj-lt"/>
+                <a:ea typeface="+mj-ea"/>
+                <a:cs typeface="+mj-cs"/>
+                <a:sym typeface="苹方-简" panose="020B0400000000000000" charset="-122"/>
+              </a:rPr>
+              <a:t>内存使能信号</a:t>
+            </a:r>
+            <a:endParaRPr kumimoji="0" lang="zh-CN" altLang="en-US" sz="1800" b="0" i="0" u="none" strike="noStrike" cap="none" spc="0" normalizeH="0" baseline="0">
+              <a:ln>
+                <a:noFill/>
+              </a:ln>
+              <a:solidFill>
+                <a:srgbClr val="000000"/>
+              </a:solidFill>
+              <a:effectLst/>
+              <a:uFillTx/>
+              <a:latin typeface="+mj-lt"/>
+              <a:ea typeface="+mj-ea"/>
+              <a:cs typeface="+mj-cs"/>
+              <a:sym typeface="苹方-简" panose="020B0400000000000000" charset="-122"/>
+            </a:endParaRPr>
+          </a:p>
+          <a:p>
+            <a:pPr marL="0" marR="0" indent="0" algn="ctr" defTabSz="914400" rtl="0" fontAlgn="auto" latinLnBrk="0" hangingPunct="0">
+              <a:lnSpc>
+                <a:spcPct val="100000"/>
+              </a:lnSpc>
+              <a:spcBef>
+                <a:spcPts val="0"/>
+              </a:spcBef>
+              <a:spcAft>
+                <a:spcPts val="0"/>
+              </a:spcAft>
+              <a:buClrTx/>
+              <a:buSzTx/>
+              <a:buFontTx/>
+              <a:buNone/>
+            </a:pPr>
+            <a:r>
+              <a:rPr kumimoji="0" lang="en-US" altLang="zh-CN" sz="1800" b="0" i="0" u="none" strike="noStrike" cap="none" spc="0" normalizeH="0" baseline="0">
+                <a:ln>
+                  <a:noFill/>
+                </a:ln>
+                <a:solidFill>
+                  <a:schemeClr val="bg1">
+                    <a:lumMod val="65000"/>
+                  </a:schemeClr>
+                </a:solidFill>
+                <a:effectLst/>
+                <a:uFillTx/>
+                <a:latin typeface="+mj-lt"/>
+                <a:ea typeface="+mj-ea"/>
+                <a:cs typeface="+mj-cs"/>
+                <a:sym typeface="苹方-简" panose="020B0400000000000000" charset="-122"/>
+              </a:rPr>
+              <a:t>to </a:t>
+            </a:r>
+            <a:r>
+              <a:rPr kumimoji="0" lang="zh-CN" altLang="en-US" sz="1800" b="0" i="0" u="none" strike="noStrike" cap="none" spc="0" normalizeH="0" baseline="0">
+                <a:ln>
+                  <a:noFill/>
+                </a:ln>
+                <a:solidFill>
+                  <a:schemeClr val="bg1">
+                    <a:lumMod val="65000"/>
+                  </a:schemeClr>
+                </a:solidFill>
+                <a:effectLst/>
+                <a:uFillTx/>
+                <a:latin typeface="+mj-lt"/>
+                <a:ea typeface="+mj-ea"/>
+                <a:cs typeface="+mj-cs"/>
+                <a:sym typeface="苹方-简" panose="020B0400000000000000" charset="-122"/>
+              </a:rPr>
+              <a:t>内存</a:t>
+            </a:r>
+            <a:br>
+              <a:rPr kumimoji="0" lang="zh-CN" altLang="en-US" sz="1800" b="0" i="0" u="none" strike="noStrike" cap="none" spc="0" normalizeH="0" baseline="0">
+                <a:ln>
+                  <a:noFill/>
+                </a:ln>
+                <a:solidFill>
+                  <a:srgbClr val="000000"/>
+                </a:solidFill>
+                <a:effectLst/>
+                <a:uFillTx/>
+                <a:latin typeface="+mj-lt"/>
+                <a:ea typeface="+mj-ea"/>
+                <a:cs typeface="+mj-cs"/>
+                <a:sym typeface="苹方-简" panose="020B0400000000000000" charset="-122"/>
+              </a:rPr>
+            </a:br>
+            <a:r>
+              <a:rPr kumimoji="0" lang="en-US" altLang="zh-CN" sz="1800" b="0" i="0" u="none" strike="noStrike" cap="none" spc="0" normalizeH="0" baseline="0">
+                <a:ln>
+                  <a:noFill/>
+                </a:ln>
+                <a:solidFill>
+                  <a:srgbClr val="000000"/>
+                </a:solidFill>
+                <a:effectLst/>
+                <a:uFillTx/>
+                <a:latin typeface="Courier New Regular" panose="02070409020205090404" charset="0"/>
+                <a:ea typeface="+mj-ea"/>
+                <a:cs typeface="Courier New Regular" panose="02070409020205090404" charset="0"/>
+                <a:sym typeface="苹方-简" panose="020B0400000000000000" charset="-122"/>
+              </a:rPr>
+              <a:t>mem_</a:t>
+            </a:r>
+            <a:r>
+              <a:rPr kumimoji="0" lang="en-US" altLang="zh-CN" sz="1800" b="0" i="0" u="none" strike="noStrike" cap="none" spc="0" normalizeH="0" baseline="0">
+                <a:ln>
+                  <a:noFill/>
+                </a:ln>
+                <a:solidFill>
+                  <a:srgbClr val="000000"/>
+                </a:solidFill>
+                <a:effectLst/>
+                <a:uFillTx/>
+                <a:latin typeface="Courier New Regular" panose="02070409020205090404" charset="0"/>
+                <a:ea typeface="+mj-ea"/>
+                <a:cs typeface="Courier New Regular" panose="02070409020205090404" charset="0"/>
+                <a:sym typeface="苹方-简" panose="020B0400000000000000" charset="-122"/>
+              </a:rPr>
+              <a:t>enable_o</a:t>
+            </a:r>
+            <a:endParaRPr kumimoji="0" lang="en-US" altLang="zh-CN" sz="1800" b="0" i="0" u="none" strike="noStrike" cap="none" spc="0" normalizeH="0" baseline="0">
+              <a:ln>
+                <a:noFill/>
+              </a:ln>
+              <a:solidFill>
+                <a:srgbClr val="000000"/>
+              </a:solidFill>
+              <a:effectLst/>
+              <a:uFillTx/>
+              <a:latin typeface="Courier New Regular" panose="02070409020205090404" charset="0"/>
+              <a:ea typeface="+mj-ea"/>
+              <a:cs typeface="Courier New Regular" panose="02070409020205090404" charset="0"/>
+              <a:sym typeface="苹方-简" panose="020B0400000000000000" charset="-122"/>
+            </a:endParaRPr>
+          </a:p>
+        </p:txBody>
+      </p:sp>
+      <p:cxnSp>
+        <p:nvCxnSpPr>
+          <p:cNvPr id="24" name="直接箭头连接符 23"/>
+          <p:cNvCxnSpPr/>
+          <p:nvPr/>
+        </p:nvCxnSpPr>
+        <p:spPr>
+          <a:xfrm>
+            <a:off x="6395720" y="5551170"/>
+            <a:ext cx="864870" cy="15875"/>
+          </a:xfrm>
+          <a:prstGeom prst="straightConnector1">
+            <a:avLst/>
+          </a:prstGeom>
+          <a:noFill/>
+          <a:ln w="12700" cap="flat">
+            <a:solidFill>
+              <a:schemeClr val="accent1"/>
+            </a:solidFill>
+            <a:prstDash val="solid"/>
+            <a:miter lim="800000"/>
+            <a:tailEnd type="arrow"/>
+          </a:ln>
+          <a:effectLst>
+            <a:outerShdw blurRad="101600" dist="50800" dir="5400000" rotWithShape="0">
+              <a:schemeClr val="accent1">
+                <a:alpha val="60000"/>
+              </a:schemeClr>
+            </a:outerShdw>
+          </a:effectLst>
+        </p:spPr>
+        <p:style>
+          <a:lnRef idx="0">
+            <a:srgbClr val="FFFFFF"/>
+          </a:lnRef>
+          <a:fillRef idx="0">
+            <a:srgbClr val="FFFFFF"/>
+          </a:fillRef>
+          <a:effectRef idx="0">
+            <a:srgbClr val="FFFFFF"/>
+          </a:effectRef>
+          <a:fontRef idx="none"/>
+        </p:style>
+      </p:cxnSp>
+      <p:sp>
+        <p:nvSpPr>
+          <p:cNvPr id="25" name="文本框 24"/>
+          <p:cNvSpPr txBox="1"/>
+          <p:nvPr/>
+        </p:nvSpPr>
+        <p:spPr>
+          <a:xfrm>
+            <a:off x="7355205" y="5306060"/>
+            <a:ext cx="1869440" cy="553720"/>
+          </a:xfrm>
+          <a:prstGeom prst="rect">
+            <a:avLst/>
+          </a:prstGeom>
+          <a:noFill/>
+          <a:ln w="12700" cap="flat">
+            <a:noFill/>
+            <a:miter lim="400000"/>
+          </a:ln>
+        </p:spPr>
+        <p:style>
+          <a:lnRef idx="0">
+            <a:srgbClr val="FFFFFF"/>
+          </a:lnRef>
+          <a:fillRef idx="0">
+            <a:srgbClr val="FFFFFF"/>
+          </a:fillRef>
+          <a:effectRef idx="0">
+            <a:srgbClr val="FFFFFF"/>
+          </a:effectRef>
+          <a:fontRef idx="none"/>
+        </p:style>
+        <p:txBody>
+          <a:bodyPr rot="0" vertOverflow="overflow" horzOverflow="overflow" vert="horz" wrap="square" lIns="0" tIns="0" rIns="0" bIns="0" numCol="1" spcCol="38100" rtlCol="0" anchor="t" forceAA="0" upright="0">
+            <a:spAutoFit/>
+          </a:bodyPr>
+          <a:p>
+            <a:pPr marL="0" marR="0" indent="0" algn="ctr" defTabSz="914400" rtl="0" fontAlgn="auto" latinLnBrk="0" hangingPunct="0">
+              <a:lnSpc>
+                <a:spcPct val="100000"/>
+              </a:lnSpc>
+              <a:spcBef>
+                <a:spcPts val="0"/>
+              </a:spcBef>
+              <a:spcAft>
+                <a:spcPts val="0"/>
+              </a:spcAft>
+              <a:buClrTx/>
+              <a:buSzTx/>
+              <a:buFontTx/>
+              <a:buNone/>
+            </a:pPr>
+            <a:r>
+              <a:rPr kumimoji="0" lang="zh-CN" altLang="en-US" sz="1800" b="0" i="0" u="none" strike="noStrike" cap="none" spc="0" normalizeH="0" baseline="0">
+                <a:ln>
+                  <a:noFill/>
+                </a:ln>
+                <a:solidFill>
+                  <a:srgbClr val="000000"/>
+                </a:solidFill>
+                <a:effectLst/>
+                <a:uFillTx/>
+                <a:latin typeface="+mj-lt"/>
+                <a:ea typeface="+mj-ea"/>
+                <a:cs typeface="+mj-cs"/>
+                <a:sym typeface="苹方-简" panose="020B0400000000000000" charset="-122"/>
+              </a:rPr>
+              <a:t>暂停信号</a:t>
+            </a:r>
+            <a:br>
+              <a:rPr kumimoji="0" lang="zh-CN" altLang="en-US" sz="1800" b="0" i="0" u="none" strike="noStrike" cap="none" spc="0" normalizeH="0" baseline="0">
+                <a:ln>
+                  <a:noFill/>
+                </a:ln>
+                <a:solidFill>
+                  <a:srgbClr val="000000"/>
+                </a:solidFill>
+                <a:effectLst/>
+                <a:uFillTx/>
+                <a:latin typeface="+mj-lt"/>
+                <a:ea typeface="+mj-ea"/>
+                <a:cs typeface="+mj-cs"/>
+                <a:sym typeface="苹方-简" panose="020B0400000000000000" charset="-122"/>
+              </a:rPr>
+            </a:br>
+            <a:r>
+              <a:rPr kumimoji="0" lang="en-US" altLang="zh-CN" sz="1800" b="0" i="0" u="none" strike="noStrike" cap="none" spc="0" normalizeH="0" baseline="0">
+                <a:ln>
+                  <a:noFill/>
+                </a:ln>
+                <a:solidFill>
+                  <a:srgbClr val="000000"/>
+                </a:solidFill>
+                <a:effectLst/>
+                <a:uFillTx/>
+                <a:latin typeface="Courier New Regular" panose="02070409020205090404" charset="0"/>
+                <a:ea typeface="+mj-ea"/>
+                <a:cs typeface="Courier New Regular" panose="02070409020205090404" charset="0"/>
+                <a:sym typeface="苹方-简" panose="020B0400000000000000" charset="-122"/>
+              </a:rPr>
+              <a:t>stall_o</a:t>
+            </a:r>
+            <a:endParaRPr kumimoji="0" lang="en-US" altLang="zh-CN" sz="1800" b="0" i="0" u="none" strike="noStrike" cap="none" spc="0" normalizeH="0" baseline="0">
+              <a:ln>
+                <a:noFill/>
+              </a:ln>
+              <a:solidFill>
+                <a:srgbClr val="000000"/>
+              </a:solidFill>
+              <a:effectLst/>
+              <a:uFillTx/>
+              <a:latin typeface="Courier New Regular" panose="02070409020205090404" charset="0"/>
+              <a:ea typeface="+mj-ea"/>
+              <a:cs typeface="Courier New Regular" panose="02070409020205090404" charset="0"/>
+              <a:sym typeface="苹方-简" panose="020B0400000000000000" charset="-122"/>
+            </a:endParaRPr>
+          </a:p>
+        </p:txBody>
+      </p:sp>
+      <p:sp>
+        <p:nvSpPr>
+          <p:cNvPr id="26" name="文本框 25"/>
+          <p:cNvSpPr txBox="1"/>
+          <p:nvPr/>
+        </p:nvSpPr>
+        <p:spPr>
+          <a:xfrm>
+            <a:off x="5519420" y="3202305"/>
+            <a:ext cx="891540" cy="322580"/>
+          </a:xfrm>
+          <a:prstGeom prst="rect">
+            <a:avLst/>
+          </a:prstGeom>
+          <a:noFill/>
+          <a:ln w="12700" cap="flat">
+            <a:noFill/>
+            <a:miter lim="400000"/>
+          </a:ln>
+        </p:spPr>
+        <p:style>
+          <a:lnRef idx="0">
+            <a:srgbClr val="FFFFFF"/>
+          </a:lnRef>
+          <a:fillRef idx="0">
+            <a:srgbClr val="FFFFFF"/>
+          </a:fillRef>
+          <a:effectRef idx="0">
+            <a:srgbClr val="FFFFFF"/>
+          </a:effectRef>
+          <a:fontRef idx="none"/>
+        </p:style>
+        <p:txBody>
+          <a:bodyPr rot="0" vertOverflow="overflow" horzOverflow="overflow" vert="horz" wrap="square" lIns="0" tIns="0" rIns="0" bIns="0" numCol="1" spcCol="38100" rtlCol="0" anchor="t" forceAA="0" upright="0">
+            <a:noAutofit/>
+          </a:bodyPr>
+          <a:p>
+            <a:pPr marL="0" marR="0" indent="0" algn="ctr" defTabSz="914400" rtl="0" fontAlgn="auto" latinLnBrk="0" hangingPunct="0">
+              <a:lnSpc>
+                <a:spcPct val="100000"/>
+              </a:lnSpc>
+              <a:spcBef>
+                <a:spcPts val="0"/>
+              </a:spcBef>
+              <a:spcAft>
+                <a:spcPts val="0"/>
+              </a:spcAft>
+              <a:buClrTx/>
+              <a:buSzTx/>
+              <a:buFontTx/>
+              <a:buNone/>
+            </a:pPr>
+            <a:r>
+              <a:rPr kumimoji="0" lang="en-US" altLang="zh-CN" sz="1800" b="0" i="0" u="none" strike="noStrike" cap="none" spc="0" normalizeH="0" baseline="0">
+                <a:ln>
+                  <a:noFill/>
+                </a:ln>
+                <a:solidFill>
+                  <a:srgbClr val="000000"/>
+                </a:solidFill>
+                <a:effectLst/>
+                <a:uFillTx/>
+                <a:latin typeface="+mj-lt"/>
+                <a:ea typeface="+mj-ea"/>
+                <a:cs typeface="+mj-cs"/>
+                <a:sym typeface="苹方-简" panose="020B0400000000000000" charset="-122"/>
+              </a:rPr>
+              <a:t>IF</a:t>
+            </a:r>
+            <a:endParaRPr kumimoji="0" lang="zh-CN" altLang="en-US" sz="1800" b="0" i="0" u="none" strike="noStrike" cap="none" spc="0" normalizeH="0" baseline="0">
+              <a:ln>
+                <a:noFill/>
+              </a:ln>
+              <a:solidFill>
+                <a:srgbClr val="000000"/>
+              </a:solidFill>
+              <a:effectLst/>
+              <a:uFillTx/>
+              <a:latin typeface="+mj-lt"/>
+              <a:ea typeface="+mj-ea"/>
+              <a:cs typeface="+mj-cs"/>
               <a:sym typeface="苹方-简" panose="020B0400000000000000" charset="-122"/>
             </a:endParaRPr>
           </a:p>

</xml_diff>